<commit_message>
Update PowerPoint for song #59 in FUBC - Українські
</commit_message>
<xml_diff>
--- a/fubc-ua/59-Прости мене, Боже (Пісні Спасенних №53).pptx
+++ b/fubc-ua/59-Прости мене, Боже (Пісні Спасенних №53).pptx
@@ -1434,7 +1434,7 @@
               <a:buNone/>
             </a:pPr>
             <a:r>
-              <a:rPr lang="en-US" sz="4500" b="1" dirty="0">
+              <a:rPr lang="en-US" sz="4300" b="1" dirty="0">
                 <a:solidFill>
                   <a:srgbClr val="FFFFFF"/>
                 </a:solidFill>
@@ -1444,14 +1444,14 @@
               </a:rPr>
               <a:t>Прости мене, Боже</a:t>
             </a:r>
-            <a:endParaRPr lang="en-US" sz="4500" dirty="0"/>
+            <a:endParaRPr lang="en-US" sz="4300" dirty="0"/>
           </a:p>
           <a:p>
             <a:pPr algn="ctr" indent="0" marL="0">
               <a:buNone/>
             </a:pPr>
             <a:r>
-              <a:rPr lang="en-US" sz="4500" b="1" dirty="0">
+              <a:rPr lang="en-US" sz="4300" b="1" dirty="0">
                 <a:solidFill>
                   <a:srgbClr val="FFFFFF"/>
                 </a:solidFill>
@@ -1461,7 +1461,7 @@
               </a:rPr>
               <a:t>(Пісні Спасенних №53)</a:t>
             </a:r>
-            <a:endParaRPr lang="en-US" sz="4500" dirty="0"/>
+            <a:endParaRPr lang="en-US" sz="4300" dirty="0"/>
           </a:p>
         </p:txBody>
       </p:sp>
@@ -1522,7 +1522,7 @@
               <a:buNone/>
             </a:pPr>
             <a:r>
-              <a:rPr lang="en-US" sz="4500" b="1" dirty="0">
+              <a:rPr lang="en-US" sz="4300" b="1" dirty="0">
                 <a:solidFill>
                   <a:srgbClr val="FFFFFF"/>
                 </a:solidFill>
@@ -1532,14 +1532,14 @@
               </a:rPr>
               <a:t>Прости мене, Боже, прости, я молю,</a:t>
             </a:r>
-            <a:endParaRPr lang="en-US" sz="4500" dirty="0"/>
+            <a:endParaRPr lang="en-US" sz="4300" dirty="0"/>
           </a:p>
           <a:p>
             <a:pPr algn="ctr" indent="0" marL="0">
               <a:buNone/>
             </a:pPr>
             <a:r>
-              <a:rPr lang="en-US" sz="4500" b="1" dirty="0">
+              <a:rPr lang="en-US" sz="4300" b="1" dirty="0">
                 <a:solidFill>
                   <a:srgbClr val="FFFFFF"/>
                 </a:solidFill>
@@ -1549,14 +1549,14 @@
               </a:rPr>
               <a:t>прости, що так пізно до Тебе я йду,</a:t>
             </a:r>
-            <a:endParaRPr lang="en-US" sz="4500" dirty="0"/>
+            <a:endParaRPr lang="en-US" sz="4300" dirty="0"/>
           </a:p>
           <a:p>
             <a:pPr algn="ctr" indent="0" marL="0">
               <a:buNone/>
             </a:pPr>
             <a:r>
-              <a:rPr lang="en-US" sz="4500" b="1" dirty="0">
+              <a:rPr lang="en-US" sz="4300" b="1" dirty="0">
                 <a:solidFill>
                   <a:srgbClr val="FFFFFF"/>
                 </a:solidFill>
@@ -1566,14 +1566,14 @@
               </a:rPr>
               <a:t>||: прости, що раніше Тебе не пізнав,</a:t>
             </a:r>
-            <a:endParaRPr lang="en-US" sz="4500" dirty="0"/>
+            <a:endParaRPr lang="en-US" sz="4300" dirty="0"/>
           </a:p>
           <a:p>
             <a:pPr algn="ctr" indent="0" marL="0">
               <a:buNone/>
             </a:pPr>
             <a:r>
-              <a:rPr lang="en-US" sz="4500" b="1" dirty="0">
+              <a:rPr lang="en-US" sz="4300" b="1" dirty="0">
                 <a:solidFill>
                   <a:srgbClr val="FFFFFF"/>
                 </a:solidFill>
@@ -1583,7 +1583,7 @@
               </a:rPr>
               <a:t>що довго у світі гріховнім блукав. :||</a:t>
             </a:r>
-            <a:endParaRPr lang="en-US" sz="4500" dirty="0"/>
+            <a:endParaRPr lang="en-US" sz="4300" dirty="0"/>
           </a:p>
         </p:txBody>
       </p:sp>
@@ -1644,7 +1644,7 @@
               <a:buNone/>
             </a:pPr>
             <a:r>
-              <a:rPr lang="en-US" sz="4500" b="1" dirty="0">
+              <a:rPr lang="en-US" sz="4300" b="1" dirty="0">
                 <a:solidFill>
                   <a:srgbClr val="FFFFFF"/>
                 </a:solidFill>
@@ -1654,14 +1654,14 @@
               </a:rPr>
               <a:t>Прости, що мій розум Тебе відхиляв,</a:t>
             </a:r>
-            <a:endParaRPr lang="en-US" sz="4500" dirty="0"/>
+            <a:endParaRPr lang="en-US" sz="4300" dirty="0"/>
           </a:p>
           <a:p>
             <a:pPr algn="ctr" indent="0" marL="0">
               <a:buNone/>
             </a:pPr>
             <a:r>
-              <a:rPr lang="en-US" sz="4500" b="1" dirty="0">
+              <a:rPr lang="en-US" sz="4300" b="1" dirty="0">
                 <a:solidFill>
                   <a:srgbClr val="FFFFFF"/>
                 </a:solidFill>
@@ -1671,14 +1671,14 @@
               </a:rPr>
               <a:t>прости, що страждати Тебе заставляв,</a:t>
             </a:r>
-            <a:endParaRPr lang="en-US" sz="4500" dirty="0"/>
+            <a:endParaRPr lang="en-US" sz="4300" dirty="0"/>
           </a:p>
           <a:p>
             <a:pPr algn="ctr" indent="0" marL="0">
               <a:buNone/>
             </a:pPr>
             <a:r>
-              <a:rPr lang="en-US" sz="4500" b="1" dirty="0">
+              <a:rPr lang="en-US" sz="4300" b="1" dirty="0">
                 <a:solidFill>
                   <a:srgbClr val="FFFFFF"/>
                 </a:solidFill>
@@ -1688,14 +1688,14 @@
               </a:rPr>
               <a:t>||: прости, що я рани Тобі завдавав,</a:t>
             </a:r>
-            <a:endParaRPr lang="en-US" sz="4500" dirty="0"/>
+            <a:endParaRPr lang="en-US" sz="4300" dirty="0"/>
           </a:p>
           <a:p>
             <a:pPr algn="ctr" indent="0" marL="0">
               <a:buNone/>
             </a:pPr>
             <a:r>
-              <a:rPr lang="en-US" sz="4500" b="1" dirty="0">
+              <a:rPr lang="en-US" sz="4300" b="1" dirty="0">
                 <a:solidFill>
                   <a:srgbClr val="FFFFFF"/>
                 </a:solidFill>
@@ -1705,7 +1705,7 @@
               </a:rPr>
               <a:t>що знов на хресті я Тебе розпинав. :||</a:t>
             </a:r>
-            <a:endParaRPr lang="en-US" sz="4500" dirty="0"/>
+            <a:endParaRPr lang="en-US" sz="4300" dirty="0"/>
           </a:p>
         </p:txBody>
       </p:sp>
@@ -1766,7 +1766,7 @@
               <a:buNone/>
             </a:pPr>
             <a:r>
-              <a:rPr lang="en-US" sz="4500" b="1" dirty="0">
+              <a:rPr lang="en-US" sz="4300" b="1" dirty="0">
                 <a:solidFill>
                   <a:srgbClr val="FFFFFF"/>
                 </a:solidFill>
@@ -1776,14 +1776,14 @@
               </a:rPr>
               <a:t>А Ти до нового життя пробудив,</a:t>
             </a:r>
-            <a:endParaRPr lang="en-US" sz="4500" dirty="0"/>
+            <a:endParaRPr lang="en-US" sz="4300" dirty="0"/>
           </a:p>
           <a:p>
             <a:pPr algn="ctr" indent="0" marL="0">
               <a:buNone/>
             </a:pPr>
             <a:r>
-              <a:rPr lang="en-US" sz="4500" b="1" dirty="0">
+              <a:rPr lang="en-US" sz="4300" b="1" dirty="0">
                 <a:solidFill>
                   <a:srgbClr val="FFFFFF"/>
                 </a:solidFill>
@@ -1793,14 +1793,14 @@
               </a:rPr>
               <a:t>і серце, і душу мені обновив,</a:t>
             </a:r>
-            <a:endParaRPr lang="en-US" sz="4500" dirty="0"/>
+            <a:endParaRPr lang="en-US" sz="4300" dirty="0"/>
           </a:p>
           <a:p>
             <a:pPr algn="ctr" indent="0" marL="0">
               <a:buNone/>
             </a:pPr>
             <a:r>
-              <a:rPr lang="en-US" sz="4500" b="1" dirty="0">
+              <a:rPr lang="en-US" sz="4300" b="1" dirty="0">
                 <a:solidFill>
                   <a:srgbClr val="FFFFFF"/>
                 </a:solidFill>
@@ -1810,14 +1810,14 @@
               </a:rPr>
               <a:t>||: і очі відкрив Ти на пройдений шлях,</a:t>
             </a:r>
-            <a:endParaRPr lang="en-US" sz="4500" dirty="0"/>
+            <a:endParaRPr lang="en-US" sz="4300" dirty="0"/>
           </a:p>
           <a:p>
             <a:pPr algn="ctr" indent="0" marL="0">
               <a:buNone/>
             </a:pPr>
             <a:r>
-              <a:rPr lang="en-US" sz="4500" b="1" dirty="0">
+              <a:rPr lang="en-US" sz="4300" b="1" dirty="0">
                 <a:solidFill>
                   <a:srgbClr val="FFFFFF"/>
                 </a:solidFill>
@@ -1827,7 +1827,7 @@
               </a:rPr>
               <a:t>не дав потонути в невірʼї, в гріхах. :||</a:t>
             </a:r>
-            <a:endParaRPr lang="en-US" sz="4500" dirty="0"/>
+            <a:endParaRPr lang="en-US" sz="4300" dirty="0"/>
           </a:p>
         </p:txBody>
       </p:sp>
@@ -1888,7 +1888,7 @@
               <a:buNone/>
             </a:pPr>
             <a:r>
-              <a:rPr lang="en-US" sz="4500" b="1" dirty="0">
+              <a:rPr lang="en-US" sz="4300" b="1" dirty="0">
                 <a:solidFill>
                   <a:srgbClr val="FFFFFF"/>
                 </a:solidFill>
@@ -1898,14 +1898,14 @@
               </a:rPr>
               <a:t>І ось я в молитві покірно стою,</a:t>
             </a:r>
-            <a:endParaRPr lang="en-US" sz="4500" dirty="0"/>
+            <a:endParaRPr lang="en-US" sz="4300" dirty="0"/>
           </a:p>
           <a:p>
             <a:pPr algn="ctr" indent="0" marL="0">
               <a:buNone/>
             </a:pPr>
             <a:r>
-              <a:rPr lang="en-US" sz="4500" b="1" dirty="0">
+              <a:rPr lang="en-US" sz="4300" b="1" dirty="0">
                 <a:solidFill>
                   <a:srgbClr val="FFFFFF"/>
                 </a:solidFill>
@@ -1915,14 +1915,14 @@
               </a:rPr>
               <a:t>життя все навіки Тобі віддаю,</a:t>
             </a:r>
-            <a:endParaRPr lang="en-US" sz="4500" dirty="0"/>
+            <a:endParaRPr lang="en-US" sz="4300" dirty="0"/>
           </a:p>
           <a:p>
             <a:pPr algn="ctr" indent="0" marL="0">
               <a:buNone/>
             </a:pPr>
             <a:r>
-              <a:rPr lang="en-US" sz="4500" b="1" dirty="0">
+              <a:rPr lang="en-US" sz="4300" b="1" dirty="0">
                 <a:solidFill>
                   <a:srgbClr val="FFFFFF"/>
                 </a:solidFill>
@@ -1932,14 +1932,14 @@
               </a:rPr>
               <a:t>||: я хочу належати тільки Тобі –</a:t>
             </a:r>
-            <a:endParaRPr lang="en-US" sz="4500" dirty="0"/>
+            <a:endParaRPr lang="en-US" sz="4300" dirty="0"/>
           </a:p>
           <a:p>
             <a:pPr algn="ctr" indent="0" marL="0">
               <a:buNone/>
             </a:pPr>
             <a:r>
-              <a:rPr lang="en-US" sz="4500" b="1" dirty="0">
+              <a:rPr lang="en-US" sz="4300" b="1" dirty="0">
                 <a:solidFill>
                   <a:srgbClr val="FFFFFF"/>
                 </a:solidFill>
@@ -1949,7 +1949,7 @@
               </a:rPr>
               <a:t>підтримай мене у земній боротьбі. :||</a:t>
             </a:r>
-            <a:endParaRPr lang="en-US" sz="4500" dirty="0"/>
+            <a:endParaRPr lang="en-US" sz="4300" dirty="0"/>
           </a:p>
         </p:txBody>
       </p:sp>
@@ -2010,7 +2010,7 @@
               <a:buNone/>
             </a:pPr>
             <a:r>
-              <a:rPr lang="en-US" sz="4500" b="1" dirty="0">
+              <a:rPr lang="en-US" sz="4300" b="1" dirty="0">
                 <a:solidFill>
                   <a:srgbClr val="FFFFFF"/>
                 </a:solidFill>
@@ -2020,14 +2020,14 @@
               </a:rPr>
               <a:t>Я словом і ділом прославлю Тебе</a:t>
             </a:r>
-            <a:endParaRPr lang="en-US" sz="4500" dirty="0"/>
+            <a:endParaRPr lang="en-US" sz="4300" dirty="0"/>
           </a:p>
           <a:p>
             <a:pPr algn="ctr" indent="0" marL="0">
               <a:buNone/>
             </a:pPr>
             <a:r>
-              <a:rPr lang="en-US" sz="4500" b="1" dirty="0">
+              <a:rPr lang="en-US" sz="4300" b="1" dirty="0">
                 <a:solidFill>
                   <a:srgbClr val="FFFFFF"/>
                 </a:solidFill>
@@ -2037,14 +2037,14 @@
               </a:rPr>
               <a:t>і вірю, що в небо Ти візьмеш мене.</a:t>
             </a:r>
-            <a:endParaRPr lang="en-US" sz="4500" dirty="0"/>
+            <a:endParaRPr lang="en-US" sz="4300" dirty="0"/>
           </a:p>
           <a:p>
             <a:pPr algn="ctr" indent="0" marL="0">
               <a:buNone/>
             </a:pPr>
             <a:r>
-              <a:rPr lang="en-US" sz="4500" b="1" dirty="0">
+              <a:rPr lang="en-US" sz="4300" b="1" dirty="0">
                 <a:solidFill>
                   <a:srgbClr val="FFFFFF"/>
                 </a:solidFill>
@@ -2054,14 +2054,14 @@
               </a:rPr>
               <a:t>||: Хай світло засяє у вчинках моїх</a:t>
             </a:r>
-            <a:endParaRPr lang="en-US" sz="4500" dirty="0"/>
+            <a:endParaRPr lang="en-US" sz="4300" dirty="0"/>
           </a:p>
           <a:p>
             <a:pPr algn="ctr" indent="0" marL="0">
               <a:buNone/>
             </a:pPr>
             <a:r>
-              <a:rPr lang="en-US" sz="4500" b="1" dirty="0">
+              <a:rPr lang="en-US" sz="4300" b="1" dirty="0">
                 <a:solidFill>
                   <a:srgbClr val="FFFFFF"/>
                 </a:solidFill>
@@ -2071,7 +2071,7 @@
               </a:rPr>
               <a:t>і вабить постійно до Тебе усіх. :||</a:t>
             </a:r>
-            <a:endParaRPr lang="en-US" sz="4500" dirty="0"/>
+            <a:endParaRPr lang="en-US" sz="4300" dirty="0"/>
           </a:p>
         </p:txBody>
       </p:sp>

</xml_diff>